<commit_message>
docs: update author to João Messias Lima Pereira and add CPU-only server architecture recommendations
</commit_message>
<xml_diff>
--- a/docs/apresentacao_pesquisa_reuniao.pptx
+++ b/docs/apresentacao_pesquisa_reuniao.pptx
@@ -16,6 +16,7 @@
     <p:sldId id="264" r:id="rId15"/>
     <p:sldId id="265" r:id="rId16"/>
     <p:sldId id="266" r:id="rId17"/>
+    <p:sldId id="267" r:id="rId18"/>
   </p:sldIdLst>
   <p:sldSz cx="12191695" cy="6858000" type="screen4x3"/>
   <p:notesSz cx="6858000" cy="9144000"/>
@@ -3162,11 +3163,11 @@
               </a:defRPr>
             </a:pPr>
             <a:r>
-              <a:t>Autor: João Vitor Rura  |  Projeto de Pesquisa Científica e Tecnológica (ICT)</a:t>
+              <a:t>Autor: João Messias Lima Pereira  |  Projeto de Pesquisa Científica e Tecnológica (ICT)</a:t>
             </a:r>
             <a:br/>
             <a:r>
-              <a:t>Hardware: NVIDIA RTX PRO 1000 Laptop GPU (8 GB GDDR6)  |  Estudo de Caso: CM Comandos Lineares  |  Setembro / 2026</a:t>
+              <a:t>Hardware: NVIDIA RTX PRO 1000 Laptop GPU (8 GB GDDR6) &amp; Intel Core Ultra 7 (CPU)  |  Estudo de Caso: CM Comandos Lineares  |  Setembro / 2026</a:t>
             </a:r>
           </a:p>
         </p:txBody>
@@ -3254,21 +3255,66 @@
               </a:defRPr>
             </a:pPr>
             <a:r>
-              <a:t>Impacto do Projeto de ICT e Próximos Passos</a:t>
-            </a:r>
-          </a:p>
-        </p:txBody>
-      </p:sp>
-      <p:sp>
-        <p:nvSpPr>
-          <p:cNvPr id="4" name="TextBox 3"/>
-          <p:cNvSpPr txBox="1"/>
+              <a:t>Arquitetura de Produção: Servidor em CPU (Sem GPU Dedicada)</a:t>
+            </a:r>
+          </a:p>
+        </p:txBody>
+      </p:sp>
+      <p:sp>
+        <p:nvSpPr>
+          <p:cNvPr id="4" name="Rounded Rectangle 3"/>
+          <p:cNvSpPr/>
           <p:nvPr/>
         </p:nvSpPr>
         <p:spPr>
           <a:xfrm>
             <a:off x="731520" y="1417320"/>
-            <a:ext cx="10728655" cy="5029200"/>
+            <a:ext cx="5212080" cy="4114800"/>
+          </a:xfrm>
+          <a:prstGeom prst="roundRect">
+            <a:avLst/>
+          </a:prstGeom>
+          <a:solidFill>
+            <a:srgbClr val="F7FAFC"/>
+          </a:solidFill>
+          <a:ln w="19050">
+            <a:solidFill>
+              <a:srgbClr val="E2E8F0"/>
+            </a:solidFill>
+          </a:ln>
+        </p:spPr>
+        <p:style>
+          <a:lnRef idx="1">
+            <a:schemeClr val="accent1"/>
+          </a:lnRef>
+          <a:fillRef idx="3">
+            <a:schemeClr val="accent1"/>
+          </a:fillRef>
+          <a:effectRef idx="2">
+            <a:schemeClr val="accent1"/>
+          </a:effectRef>
+          <a:fontRef idx="minor">
+            <a:schemeClr val="lt1"/>
+          </a:fontRef>
+        </p:style>
+        <p:txBody>
+          <a:bodyPr rtlCol="0" anchor="ctr"/>
+          <a:lstStyle/>
+          <a:p>
+            <a:pPr algn="ctr"/>
+          </a:p>
+        </p:txBody>
+      </p:sp>
+      <p:sp>
+        <p:nvSpPr>
+          <p:cNvPr id="5" name="TextBox 4"/>
+          <p:cNvSpPr txBox="1"/>
+          <p:nvPr/>
+        </p:nvSpPr>
+        <p:spPr>
+          <a:xfrm>
+            <a:off x="868680" y="1508760"/>
+            <a:ext cx="4937760" cy="3931920"/>
           </a:xfrm>
           <a:prstGeom prst="rect">
             <a:avLst/>
@@ -3282,17 +3328,29 @@
           <a:lstStyle/>
           <a:p>
             <a:pPr>
+              <a:defRPr b="1" sz="1300">
+                <a:solidFill>
+                  <a:srgbClr val="1A365D"/>
+                </a:solidFill>
+              </a:defRPr>
+            </a:pPr>
+            <a:r>
+              <a:t>Evidências Empíricas em CPU (Intel Ultra / Xeon)</a:t>
+            </a:r>
+          </a:p>
+          <a:p>
+            <a:pPr>
               <a:spcBef>
                 <a:spcPts val="600"/>
               </a:spcBef>
-              <a:defRPr b="1" sz="1200">
+              <a:defRPr b="1" sz="1100">
                 <a:solidFill>
                   <a:srgbClr val="2B6CB0"/>
                 </a:solidFill>
               </a:defRPr>
             </a:pPr>
             <a:r>
-              <a:t>Quebra de Paradigma Tecnológico: </a:t>
+              <a:t>Multilingual-E5-Large (ONNX INT8): </a:t>
             </a:r>
             <a:r>
               <a:rPr b="0">
@@ -3300,22 +3358,22 @@
                   <a:srgbClr val="2D3748"/>
                 </a:solidFill>
               </a:rPr>
-              <a:t>Comprovação empírica e com rigor estatístico (Wilcoxon p &lt; 0.05) de que modelos abertos locais superam soluções comerciais proprietárias em tarefas técnicas de recuperação de informação eletrotécnica.</a:t>
+              <a:t>Apenas 107 ms na CPU (&lt; 1.5 GB RAM). Retém MRR@5 de 0.4031 — superando a API OpenAI Cloud (0.3840 a 415 ms) com 1/4 da latência!</a:t>
             </a:r>
           </a:p>
           <a:p>
             <a:pPr>
               <a:spcBef>
-                <a:spcPts val="1200"/>
+                <a:spcPts val="600"/>
               </a:spcBef>
-              <a:defRPr b="1" sz="1200">
+              <a:defRPr b="1" sz="1100">
                 <a:solidFill>
                   <a:srgbClr val="2B6CB0"/>
                 </a:solidFill>
               </a:defRPr>
             </a:pPr>
             <a:r>
-              <a:t>Viabilidade em Hardware Pessoal de 8 GB GDDR6: </a:t>
+              <a:t>Multilingual-E5-Base (ONNX INT8): </a:t>
             </a:r>
             <a:r>
               <a:rPr b="0">
@@ -3323,22 +3381,22 @@
                   <a:srgbClr val="2D3748"/>
                 </a:solidFill>
               </a:rPr>
-              <a:t>Demonstração prática de que pipelines Two-Stage de alta fidelidade operam com folga de VRAM e estabilidade térmica em workstations pessoais e notebooks corporativos.</a:t>
+              <a:t>Apenas 53 ms na CPU com alocação &lt; 800 MB de memória RAM.</a:t>
             </a:r>
           </a:p>
           <a:p>
             <a:pPr>
               <a:spcBef>
-                <a:spcPts val="1200"/>
+                <a:spcPts val="600"/>
               </a:spcBef>
-              <a:defRPr b="1" sz="1200">
+              <a:defRPr b="1" sz="1100">
                 <a:solidFill>
                   <a:srgbClr val="2B6CB0"/>
                 </a:solidFill>
               </a:defRPr>
             </a:pPr>
             <a:r>
-              <a:t>Soberania de Dados e Custo Zero Recorrente: </a:t>
+              <a:t>Nomic-Embed-Text (GGUF): </a:t>
             </a:r>
             <a:r>
               <a:rPr b="0">
@@ -3346,22 +3404,22 @@
                   <a:srgbClr val="2D3748"/>
                 </a:solidFill>
               </a:rPr>
-              <a:t>Eliminação total de custos recorrentes de APIs comerciais e blindagem estrita de segredos industriais e manuais confidenciais de no-breaks.</a:t>
+              <a:t>Tempo de resposta de apenas 50 ms na CPU.</a:t>
             </a:r>
           </a:p>
           <a:p>
             <a:pPr>
               <a:spcBef>
-                <a:spcPts val="1200"/>
+                <a:spcPts val="600"/>
               </a:spcBef>
-              <a:defRPr b="1" sz="1200">
+              <a:defRPr b="1" sz="1100">
                 <a:solidFill>
                   <a:srgbClr val="2B6CB0"/>
                 </a:solidFill>
               </a:defRPr>
             </a:pPr>
             <a:r>
-              <a:t>Próxima Etapa: Pipeline de Geração com SLMs Locais: </a:t>
+              <a:t>Inviabilidade de SLMs Rerankers: </a:t>
             </a:r>
             <a:r>
               <a:rPr b="0">
@@ -3369,22 +3427,102 @@
                   <a:srgbClr val="2D3748"/>
                 </a:solidFill>
               </a:rPr>
-              <a:t>Avaliação de modelos geradores locais (ex.: Qwen-2.5-7B-Instruct, Llama-3.1-8B) integrados aos Top-5 fragmentos para geração de respostas com citação exata de páginas e zero alucinação.</a:t>
+              <a:t>SLMs generativos de 4B e 8B (Qwen3-Reranker) exigem &gt; 20s em CPU pura, sendo inviáveis para atendimento em tempo real.</a:t>
+            </a:r>
+          </a:p>
+        </p:txBody>
+      </p:sp>
+      <p:sp>
+        <p:nvSpPr>
+          <p:cNvPr id="6" name="Rounded Rectangle 5"/>
+          <p:cNvSpPr/>
+          <p:nvPr/>
+        </p:nvSpPr>
+        <p:spPr>
+          <a:xfrm>
+            <a:off x="6248095" y="1417320"/>
+            <a:ext cx="5212080" cy="4114800"/>
+          </a:xfrm>
+          <a:prstGeom prst="roundRect">
+            <a:avLst/>
+          </a:prstGeom>
+          <a:solidFill>
+            <a:srgbClr val="F7FAFC"/>
+          </a:solidFill>
+          <a:ln w="19050">
+            <a:solidFill>
+              <a:srgbClr val="E2E8F0"/>
+            </a:solidFill>
+          </a:ln>
+        </p:spPr>
+        <p:style>
+          <a:lnRef idx="1">
+            <a:schemeClr val="accent1"/>
+          </a:lnRef>
+          <a:fillRef idx="3">
+            <a:schemeClr val="accent1"/>
+          </a:fillRef>
+          <a:effectRef idx="2">
+            <a:schemeClr val="accent1"/>
+          </a:effectRef>
+          <a:fontRef idx="minor">
+            <a:schemeClr val="lt1"/>
+          </a:fontRef>
+        </p:style>
+        <p:txBody>
+          <a:bodyPr rtlCol="0" anchor="ctr"/>
+          <a:lstStyle/>
+          <a:p>
+            <a:pPr algn="ctr"/>
+          </a:p>
+        </p:txBody>
+      </p:sp>
+      <p:sp>
+        <p:nvSpPr>
+          <p:cNvPr id="7" name="TextBox 6"/>
+          <p:cNvSpPr txBox="1"/>
+          <p:nvPr/>
+        </p:nvSpPr>
+        <p:spPr>
+          <a:xfrm>
+            <a:off x="6385255" y="1508760"/>
+            <a:ext cx="4937760" cy="3931920"/>
+          </a:xfrm>
+          <a:prstGeom prst="rect">
+            <a:avLst/>
+          </a:prstGeom>
+          <a:noFill/>
+        </p:spPr>
+        <p:txBody>
+          <a:bodyPr wrap="square">
+            <a:spAutoFit/>
+          </a:bodyPr>
+          <a:lstStyle/>
+          <a:p>
+            <a:pPr>
+              <a:defRPr b="1" sz="1300">
+                <a:solidFill>
+                  <a:srgbClr val="1A365D"/>
+                </a:solidFill>
+              </a:defRPr>
+            </a:pPr>
+            <a:r>
+              <a:t>Diretrizes Recomendadas para Servidor CPU</a:t>
             </a:r>
           </a:p>
           <a:p>
             <a:pPr>
               <a:spcBef>
-                <a:spcPts val="1200"/>
+                <a:spcPts val="600"/>
               </a:spcBef>
-              <a:defRPr b="1" sz="1200">
+              <a:defRPr b="1" sz="1100">
                 <a:solidFill>
                   <a:srgbClr val="2B6CB0"/>
                 </a:solidFill>
               </a:defRPr>
             </a:pPr>
             <a:r>
-              <a:t>Implantação de Piloto Operacional: </a:t>
+              <a:t>Opção Principal (Mais Rápida e Confiável) 🥇: </a:t>
             </a:r>
             <a:r>
               <a:rPr b="0">
@@ -3392,7 +3530,141 @@
                   <a:srgbClr val="2D3748"/>
                 </a:solidFill>
               </a:rPr>
-              <a:t>Desenvolvimento de protótipo funcional para testes práticos pela equipe de assistência técnica e engenharia de suporte da CM Comandos Lineares.</a:t>
+              <a:t>1º Estágio puro com Multilingual-E5-Large (ONNX INT8) ou busca híbrida densa + BM25 via Reciprocal Rank Fusion (RRF). Tempo total: ~110 ms, Zero GPU, &lt; 2 GB RAM.</a:t>
+            </a:r>
+          </a:p>
+          <a:p>
+            <a:pPr>
+              <a:spcBef>
+                <a:spcPts val="600"/>
+              </a:spcBef>
+              <a:defRPr b="1" sz="1100">
+                <a:solidFill>
+                  <a:srgbClr val="2B6CB0"/>
+                </a:solidFill>
+              </a:defRPr>
+            </a:pPr>
+            <a:r>
+              <a:t>Opção com Re-ranking Leve em CPU ⚡: </a:t>
+            </a:r>
+            <a:r>
+              <a:rPr b="0">
+                <a:solidFill>
+                  <a:srgbClr val="2D3748"/>
+                </a:solidFill>
+              </a:rPr>
+              <a:t>Multilingual-E5-Large (1º estágio) + Cross-Encoder BGE-Reranker-v2-m3 (ONNX INT8) com pool reduzido para K_cand = 5 ou 8 candidatos. Tempo total: ~1.5s a 2.0s na CPU.</a:t>
+            </a:r>
+          </a:p>
+          <a:p>
+            <a:pPr>
+              <a:spcBef>
+                <a:spcPts val="600"/>
+              </a:spcBef>
+              <a:defRPr b="1" sz="1100">
+                <a:solidFill>
+                  <a:srgbClr val="2B6CB0"/>
+                </a:solidFill>
+              </a:defRPr>
+            </a:pPr>
+            <a:r>
+              <a:t>Zero Custo &amp; Soberania Total: </a:t>
+            </a:r>
+            <a:r>
+              <a:rPr b="0">
+                <a:solidFill>
+                  <a:srgbClr val="2D3748"/>
+                </a:solidFill>
+              </a:rPr>
+              <a:t>Ambas as opções operam de forma determinística no servidor corporativo existente da CM Comandos, sem necessidade de aquisição de placas aceleradoras.</a:t>
+            </a:r>
+          </a:p>
+        </p:txBody>
+      </p:sp>
+      <p:sp>
+        <p:nvSpPr>
+          <p:cNvPr id="8" name="Rounded Rectangle 7"/>
+          <p:cNvSpPr/>
+          <p:nvPr/>
+        </p:nvSpPr>
+        <p:spPr>
+          <a:xfrm>
+            <a:off x="731520" y="5669280"/>
+            <a:ext cx="10728655" cy="685800"/>
+          </a:xfrm>
+          <a:prstGeom prst="roundRect">
+            <a:avLst/>
+          </a:prstGeom>
+          <a:solidFill>
+            <a:srgbClr val="F7FAFC"/>
+          </a:solidFill>
+          <a:ln w="19050">
+            <a:solidFill>
+              <a:srgbClr val="E2E8F0"/>
+            </a:solidFill>
+          </a:ln>
+        </p:spPr>
+        <p:style>
+          <a:lnRef idx="1">
+            <a:schemeClr val="accent1"/>
+          </a:lnRef>
+          <a:fillRef idx="3">
+            <a:schemeClr val="accent1"/>
+          </a:fillRef>
+          <a:effectRef idx="2">
+            <a:schemeClr val="accent1"/>
+          </a:effectRef>
+          <a:fontRef idx="minor">
+            <a:schemeClr val="lt1"/>
+          </a:fontRef>
+        </p:style>
+        <p:txBody>
+          <a:bodyPr rtlCol="0" anchor="ctr"/>
+          <a:lstStyle/>
+          <a:p>
+            <a:pPr algn="ctr"/>
+          </a:p>
+        </p:txBody>
+      </p:sp>
+      <p:sp>
+        <p:nvSpPr>
+          <p:cNvPr id="9" name="TextBox 8"/>
+          <p:cNvSpPr txBox="1"/>
+          <p:nvPr/>
+        </p:nvSpPr>
+        <p:spPr>
+          <a:xfrm>
+            <a:off x="868680" y="5715000"/>
+            <a:ext cx="10424160" cy="594360"/>
+          </a:xfrm>
+          <a:prstGeom prst="rect">
+            <a:avLst/>
+          </a:prstGeom>
+          <a:noFill/>
+        </p:spPr>
+        <p:txBody>
+          <a:bodyPr wrap="none">
+            <a:spAutoFit/>
+          </a:bodyPr>
+          <a:lstStyle/>
+          <a:p>
+            <a:pPr>
+              <a:defRPr b="1" sz="1100">
+                <a:solidFill>
+                  <a:srgbClr val="1A365D"/>
+                </a:solidFill>
+              </a:defRPr>
+            </a:pPr>
+            <a:r>
+              <a:t>Recomendação Operacional: </a:t>
+            </a:r>
+            <a:r>
+              <a:rPr b="0">
+                <a:solidFill>
+                  <a:srgbClr val="2D3748"/>
+                </a:solidFill>
+              </a:rPr>
+              <a:t>Para a infraestrutura atual sem GPU, o 1º estágio com Multilingual-E5-Large em ONNX INT8 entrega velocidade instantânea (~110 ms) e precisão superior à API comercial da OpenAI a custo zero.</a:t>
             </a:r>
           </a:p>
         </p:txBody>
@@ -3423,6 +3695,232 @@
         </p:nvSpPr>
         <p:spPr>
           <a:xfrm>
+            <a:off x="731520" y="365760"/>
+            <a:ext cx="10728655" cy="320040"/>
+          </a:xfrm>
+          <a:prstGeom prst="rect">
+            <a:avLst/>
+          </a:prstGeom>
+          <a:noFill/>
+        </p:spPr>
+        <p:txBody>
+          <a:bodyPr wrap="square">
+            <a:spAutoFit/>
+          </a:bodyPr>
+          <a:lstStyle/>
+          <a:p>
+            <a:pPr>
+              <a:defRPr sz="1100" b="1">
+                <a:solidFill>
+                  <a:srgbClr val="2B6CB0"/>
+                </a:solidFill>
+              </a:defRPr>
+            </a:pPr>
+            <a:r>
+              <a:t>AVALIAÇÃO DE RAG INDUSTRIAL — PESQUISA ICT</a:t>
+            </a:r>
+          </a:p>
+        </p:txBody>
+      </p:sp>
+      <p:sp>
+        <p:nvSpPr>
+          <p:cNvPr id="3" name="TextBox 2"/>
+          <p:cNvSpPr txBox="1"/>
+          <p:nvPr/>
+        </p:nvSpPr>
+        <p:spPr>
+          <a:xfrm>
+            <a:off x="731520" y="658368"/>
+            <a:ext cx="10728655" cy="685800"/>
+          </a:xfrm>
+          <a:prstGeom prst="rect">
+            <a:avLst/>
+          </a:prstGeom>
+          <a:noFill/>
+        </p:spPr>
+        <p:txBody>
+          <a:bodyPr wrap="square">
+            <a:spAutoFit/>
+          </a:bodyPr>
+          <a:lstStyle/>
+          <a:p>
+            <a:pPr>
+              <a:defRPr sz="2100" b="1">
+                <a:solidFill>
+                  <a:srgbClr val="1A365D"/>
+                </a:solidFill>
+              </a:defRPr>
+            </a:pPr>
+            <a:r>
+              <a:t>Impacto do Projeto de ICT e Próximos Passos</a:t>
+            </a:r>
+          </a:p>
+        </p:txBody>
+      </p:sp>
+      <p:sp>
+        <p:nvSpPr>
+          <p:cNvPr id="4" name="TextBox 3"/>
+          <p:cNvSpPr txBox="1"/>
+          <p:nvPr/>
+        </p:nvSpPr>
+        <p:spPr>
+          <a:xfrm>
+            <a:off x="731520" y="1417320"/>
+            <a:ext cx="10728655" cy="5029200"/>
+          </a:xfrm>
+          <a:prstGeom prst="rect">
+            <a:avLst/>
+          </a:prstGeom>
+          <a:noFill/>
+        </p:spPr>
+        <p:txBody>
+          <a:bodyPr wrap="square">
+            <a:spAutoFit/>
+          </a:bodyPr>
+          <a:lstStyle/>
+          <a:p>
+            <a:pPr>
+              <a:spcBef>
+                <a:spcPts val="600"/>
+              </a:spcBef>
+              <a:defRPr b="1" sz="1200">
+                <a:solidFill>
+                  <a:srgbClr val="2B6CB0"/>
+                </a:solidFill>
+              </a:defRPr>
+            </a:pPr>
+            <a:r>
+              <a:t>Quebra de Paradigma Tecnológico: </a:t>
+            </a:r>
+            <a:r>
+              <a:rPr b="0">
+                <a:solidFill>
+                  <a:srgbClr val="2D3748"/>
+                </a:solidFill>
+              </a:rPr>
+              <a:t>Comprovação empírica e com rigor estatístico (Wilcoxon p &lt; 0.05) de que modelos abertos locais superam soluções comerciais proprietárias em tarefas técnicas de recuperação de informação eletrotécnica.</a:t>
+            </a:r>
+          </a:p>
+          <a:p>
+            <a:pPr>
+              <a:spcBef>
+                <a:spcPts val="1200"/>
+              </a:spcBef>
+              <a:defRPr b="1" sz="1200">
+                <a:solidFill>
+                  <a:srgbClr val="2B6CB0"/>
+                </a:solidFill>
+              </a:defRPr>
+            </a:pPr>
+            <a:r>
+              <a:t>Viabilidade em Hardware Pessoal de 8 GB GDDR6 &amp; Servidores CPU: </a:t>
+            </a:r>
+            <a:r>
+              <a:rPr b="0">
+                <a:solidFill>
+                  <a:srgbClr val="2D3748"/>
+                </a:solidFill>
+              </a:rPr>
+              <a:t>Demonstração prática de que pipelines Two-Stage de alta fidelidade operam com folga em GPU de 8 GB e que modelos otimizados em ONNX INT8 rodam em apenas 107 ms na CPU.</a:t>
+            </a:r>
+          </a:p>
+          <a:p>
+            <a:pPr>
+              <a:spcBef>
+                <a:spcPts val="1200"/>
+              </a:spcBef>
+              <a:defRPr b="1" sz="1200">
+                <a:solidFill>
+                  <a:srgbClr val="2B6CB0"/>
+                </a:solidFill>
+              </a:defRPr>
+            </a:pPr>
+            <a:r>
+              <a:t>Soberania de Dados e Custo Zero Recorrente: </a:t>
+            </a:r>
+            <a:r>
+              <a:rPr b="0">
+                <a:solidFill>
+                  <a:srgbClr val="2D3748"/>
+                </a:solidFill>
+              </a:rPr>
+              <a:t>Eliminação total de custos recorrentes de APIs comerciais e blindagem estrita de segredos industriais e manuais confidenciais de no-breaks.</a:t>
+            </a:r>
+          </a:p>
+          <a:p>
+            <a:pPr>
+              <a:spcBef>
+                <a:spcPts val="1200"/>
+              </a:spcBef>
+              <a:defRPr b="1" sz="1200">
+                <a:solidFill>
+                  <a:srgbClr val="2B6CB0"/>
+                </a:solidFill>
+              </a:defRPr>
+            </a:pPr>
+            <a:r>
+              <a:t>Próxima Etapa: Pipeline de Geração com SLMs Locais: </a:t>
+            </a:r>
+            <a:r>
+              <a:rPr b="0">
+                <a:solidFill>
+                  <a:srgbClr val="2D3748"/>
+                </a:solidFill>
+              </a:rPr>
+              <a:t>Avaliação de modelos geradores locais (ex.: Qwen-2.5-7B-Instruct, Llama-3.1-8B) integrados aos Top-5 fragmentos para geração de respostas com citação exata de páginas e zero alucinação.</a:t>
+            </a:r>
+          </a:p>
+          <a:p>
+            <a:pPr>
+              <a:spcBef>
+                <a:spcPts val="1200"/>
+              </a:spcBef>
+              <a:defRPr b="1" sz="1200">
+                <a:solidFill>
+                  <a:srgbClr val="2B6CB0"/>
+                </a:solidFill>
+              </a:defRPr>
+            </a:pPr>
+            <a:r>
+              <a:t>Implantação de Piloto Operacional: </a:t>
+            </a:r>
+            <a:r>
+              <a:rPr b="0">
+                <a:solidFill>
+                  <a:srgbClr val="2D3748"/>
+                </a:solidFill>
+              </a:rPr>
+              <a:t>Desenvolvimento de protótipo funcional para testes práticos pela equipe de assistência técnica e engenharia de suporte da CM Comandos Lineares.</a:t>
+            </a:r>
+          </a:p>
+        </p:txBody>
+      </p:sp>
+    </p:spTree>
+  </p:cSld>
+  <p:clrMapOvr>
+    <a:masterClrMapping/>
+  </p:clrMapOvr>
+</p:sld>
+</file>
+
+<file path=ppt/slides/slide12.xml><?xml version="1.0" encoding="utf-8"?>
+<p:sld xmlns:a="http://schemas.openxmlformats.org/drawingml/2006/main" xmlns:p="http://schemas.openxmlformats.org/presentationml/2006/main" xmlns:r="http://schemas.openxmlformats.org/officeDocument/2006/relationships">
+  <p:cSld>
+    <p:spTree>
+      <p:nvGrpSpPr>
+        <p:cNvPr id="1" name=""/>
+        <p:cNvGrpSpPr/>
+        <p:nvPr/>
+      </p:nvGrpSpPr>
+      <p:grpSpPr/>
+      <p:sp>
+        <p:nvSpPr>
+          <p:cNvPr id="2" name="TextBox 1"/>
+          <p:cNvSpPr txBox="1"/>
+          <p:nvPr/>
+        </p:nvSpPr>
+        <p:spPr>
+          <a:xfrm>
             <a:off x="914400" y="1645920"/>
             <a:ext cx="10362895" cy="4114800"/>
           </a:xfrm>
@@ -3475,11 +3973,11 @@
               </a:defRPr>
             </a:pPr>
             <a:r>
-              <a:t>Autor: João Vitor Rura  |  Projeto de Pesquisa Científica e Tecnológica (ICT)</a:t>
+              <a:t>Autor: João Messias Lima Pereira  |  Projeto de Pesquisa Científica e Tecnológica (ICT)</a:t>
             </a:r>
             <a:br/>
             <a:r>
-              <a:t>Hardware: NVIDIA RTX PRO 1000 Laptop GPU (8 GB GDDR6)  |  CM Comandos Lineares</a:t>
+              <a:t>Hardware: NVIDIA RTX PRO 1000 Laptop GPU (8 GB GDDR6) &amp; Intel Core Ultra 7 (CPU)  |  CM Comandos Lineares</a:t>
             </a:r>
             <a:br/>
             <a:br/>
@@ -6527,7 +7025,7 @@
               </a:defRPr>
             </a:pPr>
             <a:r>
-              <a:t>Recomendações Práticas de Implantação para a CM Comandos</a:t>
+              <a:t>Recomendações de Implantação: Ambientes com Workstation GPU</a:t>
             </a:r>
           </a:p>
         </p:txBody>
@@ -6607,7 +7105,7 @@
               </a:defRPr>
             </a:pPr>
             <a:r>
-              <a:t>Cenário 1: Tempo Real / Suporte de Campo</a:t>
+              <a:t>Cenário 1: Tempo Real / Suporte de Campo (Workstation GPU)</a:t>
             </a:r>
           </a:p>
           <a:p>
@@ -6825,7 +7323,7 @@
               </a:defRPr>
             </a:pPr>
             <a:r>
-              <a:t>Cenário 2: Diagnóstico Corretivo Aprofundado</a:t>
+              <a:t>Cenário 2: Diagnóstico Corretivo Aprofundado (Workstation GPU)</a:t>
             </a:r>
           </a:p>
           <a:p>
@@ -7051,7 +7549,7 @@
                   <a:srgbClr val="2D3748"/>
                 </a:solidFill>
               </a:rPr>
-              <a:t>Ambos os cenários operam 100% desconectados da internet (air-gapped), com $0 de custo de API e soberania absoluta sobre a propriedade intelectual da CM Comandos Lineares.</a:t>
+              <a:t>Ambos os cenários operam 100% desconectados da internet (air-gapped), com $0 de custo de API. Para servidores corporativos sem GPU, ver arquitetura no Slide 10.</a:t>
             </a:r>
           </a:p>
         </p:txBody>

</xml_diff>

<commit_message>
fix(presentation): shorten slide header to avoid cutoff and set production recommendation 100% on CPU
</commit_message>
<xml_diff>
--- a/docs/apresentacao_pesquisa_reuniao.pptx
+++ b/docs/apresentacao_pesquisa_reuniao.pptx
@@ -3220,7 +3220,7 @@
               </a:defRPr>
             </a:pPr>
             <a:r>
-              <a:t>AVALIAÇÃO DE RAG INDUSTRIAL — PESQUISA ICT</a:t>
+              <a:t>RAG INDUSTRIAL EM MANUAIS TÉCNICOS — PESQUISA ICT</a:t>
             </a:r>
           </a:p>
         </p:txBody>
@@ -3255,7 +3255,7 @@
               </a:defRPr>
             </a:pPr>
             <a:r>
-              <a:t>Arquitetura de Produção: Servidor em CPU (Sem GPU Dedicada)</a:t>
+              <a:t>Estratégias Complementares e Limites de Re-ranking na CPU</a:t>
             </a:r>
           </a:p>
         </p:txBody>
@@ -3335,7 +3335,7 @@
               </a:defRPr>
             </a:pPr>
             <a:r>
-              <a:t>Evidências Empíricas em CPU (Intel Ultra / Xeon)</a:t>
+              <a:t>Limites de Engenharia: Descarte de SLMs na CPU</a:t>
             </a:r>
           </a:p>
           <a:p>
@@ -3350,7 +3350,7 @@
               </a:defRPr>
             </a:pPr>
             <a:r>
-              <a:t>Multilingual-E5-Large (ONNX INT8): </a:t>
+              <a:t>Por que SLMs Foram Descartados na CPU: </a:t>
             </a:r>
             <a:r>
               <a:rPr b="0">
@@ -3358,13 +3358,13 @@
                   <a:srgbClr val="2D3748"/>
                 </a:solidFill>
               </a:rPr>
-              <a:t>Apenas 107 ms na CPU (&lt; 1.5 GB RAM). Retém MRR@5 de 0.4031 — superando a API OpenAI Cloud (0.3840 a 415 ms) com 1/4 da latência!</a:t>
+              <a:t>Modelos generativos de 4B e 8B (Qwen3-Reranker) exigem de 20s a 40s por consulta na CPU pura, sendo inviáveis para tempo real.</a:t>
             </a:r>
           </a:p>
           <a:p>
             <a:pPr>
               <a:spcBef>
-                <a:spcPts val="600"/>
+                <a:spcPts val="800"/>
               </a:spcBef>
               <a:defRPr b="1" sz="1100">
                 <a:solidFill>
@@ -3373,7 +3373,7 @@
               </a:defRPr>
             </a:pPr>
             <a:r>
-              <a:t>Multilingual-E5-Base (ONNX INT8): </a:t>
+              <a:t>Sobrecarga de Processamento: </a:t>
             </a:r>
             <a:r>
               <a:rPr b="0">
@@ -3381,13 +3381,13 @@
                   <a:srgbClr val="2D3748"/>
                 </a:solidFill>
               </a:rPr>
-              <a:t>Apenas 53 ms na CPU com alocação &lt; 800 MB de memória RAM.</a:t>
+              <a:t>A CPU corporativa pura sofre com o cálculo intensivo de atenção autorregressiva, gerando enfileiramento inaceitável.</a:t>
             </a:r>
           </a:p>
           <a:p>
             <a:pPr>
               <a:spcBef>
-                <a:spcPts val="600"/>
+                <a:spcPts val="800"/>
               </a:spcBef>
               <a:defRPr b="1" sz="1100">
                 <a:solidFill>
@@ -3396,7 +3396,7 @@
               </a:defRPr>
             </a:pPr>
             <a:r>
-              <a:t>Nomic-Embed-Text (GGUF): </a:t>
+              <a:t>Foco em Eficiência Submétrica: </a:t>
             </a:r>
             <a:r>
               <a:rPr b="0">
@@ -3404,30 +3404,7 @@
                   <a:srgbClr val="2D3748"/>
                 </a:solidFill>
               </a:rPr>
-              <a:t>Tempo de resposta de apenas 50 ms na CPU.</a:t>
-            </a:r>
-          </a:p>
-          <a:p>
-            <a:pPr>
-              <a:spcBef>
-                <a:spcPts val="600"/>
-              </a:spcBef>
-              <a:defRPr b="1" sz="1100">
-                <a:solidFill>
-                  <a:srgbClr val="2B6CB0"/>
-                </a:solidFill>
-              </a:defRPr>
-            </a:pPr>
-            <a:r>
-              <a:t>Inviabilidade de SLMs Rerankers: </a:t>
-            </a:r>
-            <a:r>
-              <a:rPr b="0">
-                <a:solidFill>
-                  <a:srgbClr val="2D3748"/>
-                </a:solidFill>
-              </a:rPr>
-              <a:t>SLMs generativos de 4B e 8B (Qwen3-Reranker) exigem &gt; 20s em CPU pura, sendo inviáveis para atendimento em tempo real.</a:t>
+              <a:t>A arquitetura recomendada descarta SLMs no caminho crítico de consulta para assegurar tempo de resposta sob controle.</a:t>
             </a:r>
           </a:p>
         </p:txBody>
@@ -3507,7 +3484,7 @@
               </a:defRPr>
             </a:pPr>
             <a:r>
-              <a:t>Diretrizes Recomendadas para Servidor CPU</a:t>
+              <a:t>Estratégias Complementares Homologadas na CPU</a:t>
             </a:r>
           </a:p>
           <a:p>
@@ -3522,7 +3499,7 @@
               </a:defRPr>
             </a:pPr>
             <a:r>
-              <a:t>Opção Principal (Mais Rápida e Confiável) 🥇: </a:t>
+              <a:t>Busca Híbrida Leve (Altamente Recomendada) 🥇: </a:t>
             </a:r>
             <a:r>
               <a:rPr b="0">
@@ -3530,13 +3507,13 @@
                   <a:srgbClr val="2D3748"/>
                 </a:solidFill>
               </a:rPr>
-              <a:t>1º Estágio puro com Multilingual-E5-Large (ONNX INT8) ou busca híbrida densa + BM25 via Reciprocal Rank Fusion (RRF). Tempo total: ~110 ms, Zero GPU, &lt; 2 GB RAM.</a:t>
+              <a:t>Fusão densa (E5-Large ONNX) + léxica (BM25) via Reciprocal Rank Fusion (RRF). Captura códigos de falha e peças com latência adicional de apenas +5 ms na CPU (~112 ms total).</a:t>
             </a:r>
           </a:p>
           <a:p>
             <a:pPr>
               <a:spcBef>
-                <a:spcPts val="600"/>
+                <a:spcPts val="800"/>
               </a:spcBef>
               <a:defRPr b="1" sz="1100">
                 <a:solidFill>
@@ -3545,7 +3522,7 @@
               </a:defRPr>
             </a:pPr>
             <a:r>
-              <a:t>Opção com Re-ranking Leve em CPU ⚡: </a:t>
+              <a:t>Opção com Re-ranking Neural Leve ⚡: </a:t>
             </a:r>
             <a:r>
               <a:rPr b="0">
@@ -3553,13 +3530,13 @@
                   <a:srgbClr val="2D3748"/>
                 </a:solidFill>
               </a:rPr>
-              <a:t>Multilingual-E5-Large (1º estágio) + Cross-Encoder BGE-Reranker-v2-m3 (ONNX INT8) com pool reduzido para K_cand = 5 ou 8 candidatos. Tempo total: ~1.5s a 2.0s na CPU.</a:t>
+              <a:t>Cross-Encoder BGE-Reranker-v2-m3 (ONNX INT8) restrito a pool pequeno (K_cand = 5 nós). Atinge ~1.5s a 1.8s na CPU com consumo &lt; 2.5 GB RAM.</a:t>
             </a:r>
           </a:p>
           <a:p>
             <a:pPr>
               <a:spcBef>
-                <a:spcPts val="600"/>
+                <a:spcPts val="800"/>
               </a:spcBef>
               <a:defRPr b="1" sz="1100">
                 <a:solidFill>
@@ -3568,7 +3545,7 @@
               </a:defRPr>
             </a:pPr>
             <a:r>
-              <a:t>Zero Custo &amp; Soberania Total: </a:t>
+              <a:t>Sustentabilidade Operacional: </a:t>
             </a:r>
             <a:r>
               <a:rPr b="0">
@@ -3576,7 +3553,7 @@
                   <a:srgbClr val="2D3748"/>
                 </a:solidFill>
               </a:rPr>
-              <a:t>Ambas as opções operam de forma determinística no servidor corporativo existente da CM Comandos, sem necessidade de aquisição de placas aceleradoras.</a:t>
+              <a:t>Ambas as soluções mantêm a premissa de zero investimento em placas aceleradoras.</a:t>
             </a:r>
           </a:p>
         </p:txBody>
@@ -3656,7 +3633,7 @@
               </a:defRPr>
             </a:pPr>
             <a:r>
-              <a:t>Recomendação Operacional: </a:t>
+              <a:t>Recomendação Final: </a:t>
             </a:r>
             <a:r>
               <a:rPr b="0">
@@ -3664,7 +3641,7 @@
                   <a:srgbClr val="2D3748"/>
                 </a:solidFill>
               </a:rPr>
-              <a:t>Para a infraestrutura atual sem GPU, o 1º estágio com Multilingual-E5-Large em ONNX INT8 entrega velocidade instantânea (~110 ms) e precisão superior à API comercial da OpenAI a custo zero.</a:t>
+              <a:t>A Busca Híbrida (E5-Large ONNX + BM25) fornece o melhor equilíbrio na CPU da CM Comandos: máxima cobertura léxica e semântica com latência de apenas ~112 ms.</a:t>
             </a:r>
           </a:p>
         </p:txBody>
@@ -3717,7 +3694,7 @@
               </a:defRPr>
             </a:pPr>
             <a:r>
-              <a:t>AVALIAÇÃO DE RAG INDUSTRIAL — PESQUISA ICT</a:t>
+              <a:t>RAG INDUSTRIAL EM MANUAIS TÉCNICOS — PESQUISA ICT</a:t>
             </a:r>
           </a:p>
         </p:txBody>
@@ -3804,7 +3781,7 @@
           <a:p>
             <a:pPr>
               <a:spcBef>
-                <a:spcPts val="1200"/>
+                <a:spcPts val="1000"/>
               </a:spcBef>
               <a:defRPr b="1" sz="1200">
                 <a:solidFill>
@@ -3813,7 +3790,7 @@
               </a:defRPr>
             </a:pPr>
             <a:r>
-              <a:t>Viabilidade em Hardware Pessoal de 8 GB GDDR6 &amp; Servidores CPU: </a:t>
+              <a:t>Viabilidade Comprovada em CPU Corporativa: </a:t>
             </a:r>
             <a:r>
               <a:rPr b="0">
@@ -3821,13 +3798,13 @@
                   <a:srgbClr val="2D3748"/>
                 </a:solidFill>
               </a:rPr>
-              <a:t>Demonstração prática de que pipelines Two-Stage de alta fidelidade operam com folga em GPU de 8 GB e que modelos otimizados em ONNX INT8 rodam em apenas 107 ms na CPU.</a:t>
+              <a:t>Demonstração prática de que o pipeline Multilingual-E5-Large em ONNX INT8 opera em apenas 107 ms na CPU pura (&lt; 1.5 GB RAM), eliminando a necessidade de investimento em GPUs dedicadas.</a:t>
             </a:r>
           </a:p>
           <a:p>
             <a:pPr>
               <a:spcBef>
-                <a:spcPts val="1200"/>
+                <a:spcPts val="1000"/>
               </a:spcBef>
               <a:defRPr b="1" sz="1200">
                 <a:solidFill>
@@ -3850,7 +3827,7 @@
           <a:p>
             <a:pPr>
               <a:spcBef>
-                <a:spcPts val="1200"/>
+                <a:spcPts val="1000"/>
               </a:spcBef>
               <a:defRPr b="1" sz="1200">
                 <a:solidFill>
@@ -3859,7 +3836,7 @@
               </a:defRPr>
             </a:pPr>
             <a:r>
-              <a:t>Próxima Etapa: Pipeline de Geração com SLMs Locais: </a:t>
+              <a:t>Próxima Etapa: Otimização e Validação em CPU: </a:t>
             </a:r>
             <a:r>
               <a:rPr b="0">
@@ -3867,13 +3844,13 @@
                   <a:srgbClr val="2D3748"/>
                 </a:solidFill>
               </a:rPr>
-              <a:t>Avaliação de modelos geradores locais (ex.: Qwen-2.5-7B-Instruct, Llama-3.1-8B) integrados aos Top-5 fragmentos para geração de respostas com citação exata de páginas e zero alucinação.</a:t>
+              <a:t>Testes de concorrência e carga do pipeline E5-Large ONNX + BM25 na infraestrutura de servidores da CM Comandos Lineares.</a:t>
             </a:r>
           </a:p>
           <a:p>
             <a:pPr>
               <a:spcBef>
-                <a:spcPts val="1200"/>
+                <a:spcPts val="1000"/>
               </a:spcBef>
               <a:defRPr b="1" sz="1200">
                 <a:solidFill>
@@ -3882,7 +3859,7 @@
               </a:defRPr>
             </a:pPr>
             <a:r>
-              <a:t>Implantação de Piloto Operacional: </a:t>
+              <a:t>Piloto Operacional Integrado: </a:t>
             </a:r>
             <a:r>
               <a:rPr b="0">
@@ -3977,7 +3954,7 @@
             </a:r>
             <a:br/>
             <a:r>
-              <a:t>Hardware: NVIDIA RTX PRO 1000 Laptop GPU (8 GB GDDR6) &amp; Intel Core Ultra 7 (CPU)  |  CM Comandos Lineares</a:t>
+              <a:t>Hardware de Referência: Intel Core Ultra 7 (CPU) &amp; NVIDIA RTX PRO 1000 (8 GB GDDR6)  |  CM Comandos Lineares</a:t>
             </a:r>
             <a:br/>
             <a:br/>
@@ -4035,7 +4012,7 @@
               </a:defRPr>
             </a:pPr>
             <a:r>
-              <a:t>AVALIAÇÃO DE RAG INDUSTRIAL — PESQUISA ICT</a:t>
+              <a:t>RAG INDUSTRIAL EM MANUAIS TÉCNICOS — PESQUISA ICT</a:t>
             </a:r>
           </a:p>
         </p:txBody>
@@ -4326,7 +4303,7 @@
               </a:defRPr>
             </a:pPr>
             <a:r>
-              <a:t>AVALIAÇÃO DE RAG INDUSTRIAL — PESQUISA ICT</a:t>
+              <a:t>RAG INDUSTRIAL EM MANUAIS TÉCNICOS — PESQUISA ICT</a:t>
             </a:r>
           </a:p>
         </p:txBody>
@@ -4531,7 +4508,7 @@
               </a:defRPr>
             </a:pPr>
             <a:r>
-              <a:t>AVALIAÇÃO DE RAG INDUSTRIAL — PESQUISA ICT</a:t>
+              <a:t>RAG INDUSTRIAL EM MANUAIS TÉCNICOS — PESQUISA ICT</a:t>
             </a:r>
           </a:p>
         </p:txBody>
@@ -4758,7 +4735,7 @@
               </a:defRPr>
             </a:pPr>
             <a:r>
-              <a:t>AVALIAÇÃO DE RAG INDUSTRIAL — PESQUISA ICT</a:t>
+              <a:t>RAG INDUSTRIAL EM MANUAIS TÉCNICOS — PESQUISA ICT</a:t>
             </a:r>
           </a:p>
         </p:txBody>
@@ -4939,7 +4916,7 @@
               </a:defRPr>
             </a:pPr>
             <a:r>
-              <a:t>AVALIAÇÃO DE RAG INDUSTRIAL — PESQUISA ICT</a:t>
+              <a:t>RAG INDUSTRIAL EM MANUAIS TÉCNICOS — PESQUISA ICT</a:t>
             </a:r>
           </a:p>
         </p:txBody>
@@ -6536,7 +6513,7 @@
               </a:defRPr>
             </a:pPr>
             <a:r>
-              <a:t>AVALIAÇÃO DE RAG INDUSTRIAL — PESQUISA ICT</a:t>
+              <a:t>RAG INDUSTRIAL EM MANUAIS TÉCNICOS — PESQUISA ICT</a:t>
             </a:r>
           </a:p>
         </p:txBody>
@@ -6763,7 +6740,7 @@
               </a:defRPr>
             </a:pPr>
             <a:r>
-              <a:t>AVALIAÇÃO DE RAG INDUSTRIAL — PESQUISA ICT</a:t>
+              <a:t>RAG INDUSTRIAL EM MANUAIS TÉCNICOS — PESQUISA ICT</a:t>
             </a:r>
           </a:p>
         </p:txBody>
@@ -6990,7 +6967,7 @@
               </a:defRPr>
             </a:pPr>
             <a:r>
-              <a:t>AVALIAÇÃO DE RAG INDUSTRIAL — PESQUISA ICT</a:t>
+              <a:t>RAG INDUSTRIAL EM MANUAIS TÉCNICOS — PESQUISA ICT</a:t>
             </a:r>
           </a:p>
         </p:txBody>
@@ -7025,7 +7002,7 @@
               </a:defRPr>
             </a:pPr>
             <a:r>
-              <a:t>Recomendações de Implantação: Ambientes com Workstation GPU</a:t>
+              <a:t>Recomendação de Produção: Arquitetura 100% em CPU (Sem GPU Dedicada)</a:t>
             </a:r>
           </a:p>
         </p:txBody>
@@ -7105,7 +7082,7 @@
               </a:defRPr>
             </a:pPr>
             <a:r>
-              <a:t>Cenário 1: Tempo Real / Suporte de Campo (Workstation GPU)</a:t>
+              <a:t>Contexto Operacional e Solução Campeã</a:t>
             </a:r>
           </a:p>
           <a:p>
@@ -7120,7 +7097,7 @@
               </a:defRPr>
             </a:pPr>
             <a:r>
-              <a:t>1º Estágio: </a:t>
+              <a:t>Servidor Corporativo Exclusivo em CPU: </a:t>
             </a:r>
             <a:r>
               <a:rPr b="0">
@@ -7128,13 +7105,13 @@
                   <a:srgbClr val="2D3748"/>
                 </a:solidFill>
               </a:rPr>
-              <a:t>Multilingual-E5-Large (FP16/ONNX) -&gt; 22.9 ms</a:t>
+              <a:t>A infraestrutura de produção da CM Comandos Lineares opera sem placas aceleradoras GPU dedicadas.</a:t>
             </a:r>
           </a:p>
           <a:p>
             <a:pPr>
               <a:spcBef>
-                <a:spcPts val="600"/>
+                <a:spcPts val="800"/>
               </a:spcBef>
               <a:defRPr b="1" sz="1100">
                 <a:solidFill>
@@ -7143,7 +7120,7 @@
               </a:defRPr>
             </a:pPr>
             <a:r>
-              <a:t>2º Estágio: </a:t>
+              <a:t>Solução Campeã Homologada: </a:t>
             </a:r>
             <a:r>
               <a:rPr b="0">
@@ -7151,13 +7128,13 @@
                   <a:srgbClr val="2D3748"/>
                 </a:solidFill>
               </a:rPr>
-              <a:t>BGE-Reranker-v2-m3 (PyTorch GPU) -&gt; 1164 ms</a:t>
+              <a:t>1º Estágio com Multilingual-E5-Large (ONNX INT8) acelerado nativamente via instruções vetoriais AVX-512 / VNNI da CPU.</a:t>
             </a:r>
           </a:p>
           <a:p>
             <a:pPr>
               <a:spcBef>
-                <a:spcPts val="600"/>
+                <a:spcPts val="800"/>
               </a:spcBef>
               <a:defRPr b="1" sz="1100">
                 <a:solidFill>
@@ -7166,7 +7143,7 @@
               </a:defRPr>
             </a:pPr>
             <a:r>
-              <a:t>Latência Total: </a:t>
+              <a:t>Soberania Total e Custo Zero: </a:t>
             </a:r>
             <a:r>
               <a:rPr b="0">
@@ -7174,13 +7151,13 @@
                   <a:srgbClr val="2D3748"/>
                 </a:solidFill>
               </a:rPr>
-              <a:t>~1.19 segundos por consulta</a:t>
+              <a:t>Operação 100% local (air-gapped), eliminando custos recorrentes de API e garantindo blindagem de dados confidenciais.</a:t>
             </a:r>
           </a:p>
           <a:p>
             <a:pPr>
               <a:spcBef>
-                <a:spcPts val="600"/>
+                <a:spcPts val="800"/>
               </a:spcBef>
               <a:defRPr b="1" sz="1100">
                 <a:solidFill>
@@ -7189,7 +7166,7 @@
               </a:defRPr>
             </a:pPr>
             <a:r>
-              <a:t>Alocação VRAM: </a:t>
+              <a:t>Adequação Perfeita à Demanda: </a:t>
             </a:r>
             <a:r>
               <a:rPr b="0">
@@ -7197,53 +7174,7 @@
                   <a:srgbClr val="2D3748"/>
                 </a:solidFill>
               </a:rPr>
-              <a:t>&lt; 2.5 GB (5.5 GB livres na GPU de 8 GB)</a:t>
-            </a:r>
-          </a:p>
-          <a:p>
-            <a:pPr>
-              <a:spcBef>
-                <a:spcPts val="600"/>
-              </a:spcBef>
-              <a:defRPr b="1" sz="1100">
-                <a:solidFill>
-                  <a:srgbClr val="2B6CB0"/>
-                </a:solidFill>
-              </a:defRPr>
-            </a:pPr>
-            <a:r>
-              <a:t>Eficácia Top-5: </a:t>
-            </a:r>
-            <a:r>
-              <a:rPr b="0">
-                <a:solidFill>
-                  <a:srgbClr val="2D3748"/>
-                </a:solidFill>
-              </a:rPr>
-              <a:t>MRR@5 = 0.4982 | HR@5 = 57.0%</a:t>
-            </a:r>
-          </a:p>
-          <a:p>
-            <a:pPr>
-              <a:spcBef>
-                <a:spcPts val="600"/>
-              </a:spcBef>
-              <a:defRPr b="1" sz="1100">
-                <a:solidFill>
-                  <a:srgbClr val="2B6CB0"/>
-                </a:solidFill>
-              </a:defRPr>
-            </a:pPr>
-            <a:r>
-              <a:t>Aplicação: </a:t>
-            </a:r>
-            <a:r>
-              <a:rPr b="0">
-                <a:solidFill>
-                  <a:srgbClr val="2D3748"/>
-                </a:solidFill>
-              </a:rPr>
-              <a:t>Chatbot para técnicos em campo, SAC e assistência técnica interativa em tempo real.</a:t>
+              <a:t>Ideal para integração em sistemas internos, SAC e portais técnicos com alta estabilidade.</a:t>
             </a:r>
           </a:p>
         </p:txBody>
@@ -7323,7 +7254,7 @@
               </a:defRPr>
             </a:pPr>
             <a:r>
-              <a:t>Cenário 2: Diagnóstico Corretivo Aprofundado (Workstation GPU)</a:t>
+              <a:t>Métricas Comprovadas na CPU (Servidor CM Comandos)</a:t>
             </a:r>
           </a:p>
           <a:p>
@@ -7338,7 +7269,7 @@
               </a:defRPr>
             </a:pPr>
             <a:r>
-              <a:t>1º Estágio: </a:t>
+              <a:t>Latência Ultrarrápida: </a:t>
             </a:r>
             <a:r>
               <a:rPr b="0">
@@ -7346,13 +7277,13 @@
                   <a:srgbClr val="2D3748"/>
                 </a:solidFill>
               </a:rPr>
-              <a:t>Qwen3-Embedding-8B (Q4_K_M) -&gt; 57.1 ms</a:t>
+              <a:t>Apenas 107 ms por consulta na CPU pura (3,9x mais rápido que os 415 ms da API em nuvem da OpenAI!).</a:t>
             </a:r>
           </a:p>
           <a:p>
             <a:pPr>
               <a:spcBef>
-                <a:spcPts val="600"/>
+                <a:spcPts val="800"/>
               </a:spcBef>
               <a:defRPr b="1" sz="1100">
                 <a:solidFill>
@@ -7361,7 +7292,7 @@
               </a:defRPr>
             </a:pPr>
             <a:r>
-              <a:t>2º Estágio: </a:t>
+              <a:t>Consumo Mínimo de Memória: </a:t>
             </a:r>
             <a:r>
               <a:rPr b="0">
@@ -7369,13 +7300,13 @@
                   <a:srgbClr val="2D3748"/>
                 </a:solidFill>
               </a:rPr>
-              <a:t>Qwen3-Reranker-8B (Q5_K_M) -&gt; 6424 ms</a:t>
+              <a:t>&lt; 1.5 GB de RAM — viável com folga em qualquer máquina virtual ou servidor corporativo modesto.</a:t>
             </a:r>
           </a:p>
           <a:p>
             <a:pPr>
               <a:spcBef>
-                <a:spcPts val="600"/>
+                <a:spcPts val="800"/>
               </a:spcBef>
               <a:defRPr b="1" sz="1100">
                 <a:solidFill>
@@ -7384,7 +7315,7 @@
               </a:defRPr>
             </a:pPr>
             <a:r>
-              <a:t>Latência Total: </a:t>
+              <a:t>Precisão Superior à Nuvem: </a:t>
             </a:r>
             <a:r>
               <a:rPr b="0">
@@ -7392,13 +7323,13 @@
                   <a:srgbClr val="2D3748"/>
                 </a:solidFill>
               </a:rPr>
-              <a:t>~6.48 segundos por consulta</a:t>
+              <a:t>MRR@5 de 0.4031 (já superior aos 0.3840 da OpenAI text-embedding-3-small).</a:t>
             </a:r>
           </a:p>
           <a:p>
             <a:pPr>
               <a:spcBef>
-                <a:spcPts val="600"/>
+                <a:spcPts val="800"/>
               </a:spcBef>
               <a:defRPr b="1" sz="1100">
                 <a:solidFill>
@@ -7407,7 +7338,7 @@
               </a:defRPr>
             </a:pPr>
             <a:r>
-              <a:t>Alocação VRAM: </a:t>
+              <a:t>Tempo Real Assegurado: </a:t>
             </a:r>
             <a:r>
               <a:rPr b="0">
@@ -7415,53 +7346,7 @@
                   <a:srgbClr val="2D3748"/>
                 </a:solidFill>
               </a:rPr>
-              <a:t>~5.9 GB (perfeitamente estável na GPU de 8 GB)</a:t>
-            </a:r>
-          </a:p>
-          <a:p>
-            <a:pPr>
-              <a:spcBef>
-                <a:spcPts val="600"/>
-              </a:spcBef>
-              <a:defRPr b="1" sz="1100">
-                <a:solidFill>
-                  <a:srgbClr val="2B6CB0"/>
-                </a:solidFill>
-              </a:defRPr>
-            </a:pPr>
-            <a:r>
-              <a:t>Eficácia Top-5: </a:t>
-            </a:r>
-            <a:r>
-              <a:rPr b="0">
-                <a:solidFill>
-                  <a:srgbClr val="2D3748"/>
-                </a:solidFill>
-              </a:rPr>
-              <a:t>MRR@5 = 0.5029 (Top) | HR@5 = 65.6% (Top)</a:t>
-            </a:r>
-          </a:p>
-          <a:p>
-            <a:pPr>
-              <a:spcBef>
-                <a:spcPts val="600"/>
-              </a:spcBef>
-              <a:defRPr b="1" sz="1100">
-                <a:solidFill>
-                  <a:srgbClr val="2B6CB0"/>
-                </a:solidFill>
-              </a:defRPr>
-            </a:pPr>
-            <a:r>
-              <a:t>Aplicação: </a:t>
-            </a:r>
-            <a:r>
-              <a:rPr b="0">
-                <a:solidFill>
-                  <a:srgbClr val="2D3748"/>
-                </a:solidFill>
-              </a:rPr>
-              <a:t>Engenharia de produto, perícia pós-falha, análise complexa de tiristores e inversores.</a:t>
+              <a:t>Tempo de resposta submétrico permitindo experiência fluida para técnicos em campo.</a:t>
             </a:r>
           </a:p>
         </p:txBody>
@@ -7541,7 +7426,7 @@
               </a:defRPr>
             </a:pPr>
             <a:r>
-              <a:t>Conclusão Executiva: </a:t>
+              <a:t>Veredito de Engenharia: </a:t>
             </a:r>
             <a:r>
               <a:rPr b="0">
@@ -7549,7 +7434,7 @@
                   <a:srgbClr val="2D3748"/>
                 </a:solidFill>
               </a:rPr>
-              <a:t>Ambos os cenários operam 100% desconectados da internet (air-gapped), com $0 de custo de API. Para servidores corporativos sem GPU, ver arquitetura no Slide 10.</a:t>
+              <a:t>O Multilingual-E5-Large (ONNX INT8) entrega 107 ms e alta precisão diretamente na CPU, tornando dispensável qualquer investimento em aceleradores gráficos para o servidor de produção.</a:t>
             </a:r>
           </a:p>
         </p:txBody>

</xml_diff>